<commit_message>
Kiem chung nguon goc du lieu: chung minh du lieu SEC la THAT, khong bia
- them scripts/verify_provenance.py + tests/test_verify_provenance.py (6 test): bam SHA-256 20 file companyfacts, tra nguoc tung fact (tag/ky/accn/form) trong snapshot SEC tho, kiem quy doi VND theo dung method (ke ca current_ytd_minus_previous_ytd), bat loi 'dien so cho du'

- ket qua: 20/20 hash khop, 4609/4609 o tra nguoc duoc trong SEC, 0 loi quy doi, 0 o bia so (703 o thieu o SEC deu la null) => reports/results/provenance.{json,md}

- audit_data: them nhom kiem tra 'provenance' (phai DAT); 98192 phep kiem tra, 0 phat hien

- run_all: them buoc provenance (21 buoc); make_report: muc 1 neu bang chung nguon goc + Phu luc B/C; docs cap nhat so test 220, so phep kiem 98192

- lam ro gioi han con lai: nhan goc 'duoc giu nguyen' tu pipeline prepare_sec (chua port) nen KHONG tai tao duoc tu SEC - da co bo nhan quy tac tai lap o data/prepared-rule + do khop 74,4%
</commit_message>
<xml_diff>
--- a/docs/BAO-CAO-slide-bao-ve.pptx
+++ b/docs/BAO-CAO-slide-bao-ve.pptx
@@ -152,7 +152,16 @@
             </a:pPr>
             <a:r>
               <a:rPr lang="vi-VN" sz="1400" b="0" dirty="0"/>
-              <a:t>Tái lập 1 lệnh · 214 test · 98.176 phép kiểm tra, 0 phát hiện</a:t>
+              <a:t>Tái lập 1 lệnh · 220 test · 98.192 phép kiểm tra, 0 phát hiện</a:t>
+            </a:r>
+          </a:p>
+          <a:p>
+            <a:pPr marL="228600" indent="-228600">
+              <a:buChar char="•"/>
+            </a:pPr>
+            <a:r>
+              <a:rPr lang="vi-VN" sz="1400" b="0" dirty="0"/>
+              <a:t>Dữ liệu SEC thật: 20 file hash khớp, 4.609 fact tra ngược, 0 bịa</a:t>
             </a:r>
           </a:p>
           <a:p>
@@ -277,7 +286,16 @@
             </a:pPr>
             <a:r>
               <a:rPr lang="vi-VN" sz="1400" b="0" dirty="0"/>
-              <a:t>214 test tự động · audit 98.176 phép kiểm tra, 0 phát hiện</a:t>
+              <a:t>Kiểm chứng dữ liệu thật: python -m scripts.verify_provenance (0 lệch)</a:t>
+            </a:r>
+          </a:p>
+          <a:p>
+            <a:pPr marL="228600" indent="-228600">
+              <a:buChar char="•"/>
+            </a:pPr>
+            <a:r>
+              <a:rPr lang="vi-VN" sz="1400" b="0" dirty="0"/>
+              <a:t>220 test tự động · audit 98.192 phép kiểm tra, 0 phát hiện</a:t>
             </a:r>
           </a:p>
         </p:txBody>

</xml_diff>

<commit_message>
Mo rong kiem chung: 4 ho mo hinh (them MLP), baseline quy tac Altman, walk-forward + cluster bootstrap, PORT ETL prepare_sec (5308/5312 o = 99.92%), nhan su kien 8-K, CI workflow; chay lai 22 buoc (234 test OK, 98200 audit 0 phat hien)
</commit_message>
<xml_diff>
--- a/docs/BAO-CAO-slide-bao-ve.pptx
+++ b/docs/BAO-CAO-slide-bao-ve.pptx
@@ -152,7 +152,7 @@
             </a:pPr>
             <a:r>
               <a:rPr lang="vi-VN" sz="1400" b="0" dirty="0"/>
-              <a:t>Tái lập 1 lệnh · 222 test · 98.200 phép kiểm tra, 0 phát hiện</a:t>
+              <a:t>Tái lập 1 lệnh · 234 test · 98.200+ phép kiểm tra, 0 phát hiện</a:t>
             </a:r>
           </a:p>
           <a:p>
@@ -295,7 +295,7 @@
             </a:pPr>
             <a:r>
               <a:rPr lang="vi-VN" sz="1400" b="0" dirty="0"/>
-              <a:t>222 test tự động · audit 98.200 phép kiểm tra, 0 phát hiện</a:t>
+              <a:t>234 test tự động · audit 98.200+ phép kiểm tra, 0 phát hiện</a:t>
             </a:r>
           </a:p>
         </p:txBody>
@@ -1007,7 +1007,7 @@
             </a:pPr>
             <a:r>
               <a:rPr lang="vi-VN" sz="2400" b="1" dirty="0"/>
-              <a:t>Ba họ mô hình và cách chọn</a:t>
+              <a:t>Bốn họ mô hình và cách chọn</a:t>
             </a:r>
           </a:p>
         </p:txBody>
@@ -1039,7 +1039,25 @@
             </a:pPr>
             <a:r>
               <a:rPr lang="vi-VN" sz="1400" b="0" dirty="0"/>
-              <a:t>Logistic Regression · Random Forest · HistGradientBoosting (3 họ, thuần scikit-learn)</a:t>
+              <a:t>Logistic Regression · Random Forest · HistGradientBoosting · MLP (4 họ, thuần scikit-learn)</a:t>
+            </a:r>
+          </a:p>
+          <a:p>
+            <a:pPr marL="228600" indent="-228600">
+              <a:buChar char="•"/>
+            </a:pPr>
+            <a:r>
+              <a:rPr lang="vi-VN" sz="1400" b="0" dirty="0"/>
+              <a:t>Baseline quy tắc Altman Z'' &lt; 1,1 (không học tham số) + ticker-prior + dummy + 1 chỉ tiêu</a:t>
+            </a:r>
+          </a:p>
+          <a:p>
+            <a:pPr marL="228600" indent="-228600">
+              <a:buChar char="•"/>
+            </a:pPr>
+            <a:r>
+              <a:rPr lang="vi-VN" sz="1400" b="0" dirty="0"/>
+              <a:t>Kiểm chứng 3 góc: in-domain · cross-company (GroupKFold/LOCO) · walk-forward theo thời gian</a:t>
             </a:r>
           </a:p>
           <a:p>
@@ -1075,16 +1093,16 @@
             </a:pPr>
             <a:r>
               <a:rPr lang="vi-VN" sz="1400" b="0" dirty="0"/>
-              <a:t>Random search + sổ thực nghiệm runs.csv (113 dòng)</a:t>
-            </a:r>
-          </a:p>
-          <a:p>
-            <a:pPr marL="228600" indent="-228600">
-              <a:buChar char="•"/>
-            </a:pPr>
-            <a:r>
-              <a:rPr lang="vi-VN" sz="1400" b="0" dirty="0"/>
-              <a:t>Chỉ 3 họ mô hình (không xgboost/lightgbm) ⇒ mọi báo cáo/slide lấy từ 1 registry</a:t>
+              <a:t>Random search + sổ thực nghiệm runs.csv (153 dòng, 4 họ mô hình)</a:t>
+            </a:r>
+          </a:p>
+          <a:p>
+            <a:pPr marL="228600" indent="-228600">
+              <a:buChar char="•"/>
+            </a:pPr>
+            <a:r>
+              <a:rPr lang="vi-VN" sz="1400" b="0" dirty="0"/>
+              <a:t>Chỉ 4 họ mô hình (không xgboost/lightgbm) ⇒ mọi báo cáo/slide lấy từ 1 registry</a:t>
             </a:r>
           </a:p>
         </p:txBody>

</xml_diff>